<commit_message>
Add spatiotemporal figures and update directional annotation
</commit_message>
<xml_diff>
--- a/tasks/bird_directional_windrose_radar/figures/overall/overall_direction_windrose.pptx
+++ b/tasks/bird_directional_windrose_radar/figures/overall/overall_direction_windrose.pptx
@@ -2659,312 +2659,312 @@
           </p:nvSpPr>
           <p:spPr>
             <a:xfrm>
-              <a:off x="3370523" y="3107500"/>
-              <a:ext cx="521085" cy="521019"/>
+              <a:off x="2344730" y="2081577"/>
+              <a:ext cx="2572672" cy="2572348"/>
             </a:xfrm>
             <a:custGeom>
               <a:avLst/>
               <a:pathLst>
-                <a:path w="521085" h="521019">
+                <a:path w="2572672" h="2572348">
                   <a:moveTo>
-                    <a:pt x="260542" y="0"/>
+                    <a:pt x="1286336" y="0"/>
                   </a:moveTo>
                   <a:lnTo>
-                    <a:pt x="277069" y="524"/>
-                  </a:lnTo>
-                  <a:lnTo>
-                    <a:pt x="293529" y="2096"/>
-                  </a:lnTo>
-                  <a:lnTo>
-                    <a:pt x="309856" y="4708"/>
-                  </a:lnTo>
-                  <a:lnTo>
-                    <a:pt x="325985" y="8351"/>
-                  </a:lnTo>
-                  <a:lnTo>
-                    <a:pt x="341850" y="13010"/>
-                  </a:lnTo>
-                  <a:lnTo>
-                    <a:pt x="357388" y="18665"/>
-                  </a:lnTo>
-                  <a:lnTo>
-                    <a:pt x="372536" y="25294"/>
-                  </a:lnTo>
-                  <a:lnTo>
-                    <a:pt x="387233" y="32871"/>
-                  </a:lnTo>
-                  <a:lnTo>
-                    <a:pt x="401420" y="41365"/>
-                  </a:lnTo>
-                  <a:lnTo>
-                    <a:pt x="415039" y="50741"/>
-                  </a:lnTo>
-                  <a:lnTo>
-                    <a:pt x="428037" y="60963"/>
-                  </a:lnTo>
-                  <a:lnTo>
-                    <a:pt x="440360" y="71988"/>
-                  </a:lnTo>
-                  <a:lnTo>
-                    <a:pt x="451959" y="83772"/>
-                  </a:lnTo>
-                  <a:lnTo>
-                    <a:pt x="462787" y="96268"/>
-                  </a:lnTo>
-                  <a:lnTo>
-                    <a:pt x="472801" y="109426"/>
-                  </a:lnTo>
-                  <a:lnTo>
-                    <a:pt x="481960" y="123193"/>
-                  </a:lnTo>
-                  <a:lnTo>
-                    <a:pt x="490227" y="137513"/>
-                  </a:lnTo>
-                  <a:lnTo>
-                    <a:pt x="497570" y="152328"/>
-                  </a:lnTo>
-                  <a:lnTo>
-                    <a:pt x="503958" y="167579"/>
-                  </a:lnTo>
-                  <a:lnTo>
-                    <a:pt x="509366" y="183205"/>
-                  </a:lnTo>
-                  <a:lnTo>
-                    <a:pt x="513772" y="199142"/>
-                  </a:lnTo>
-                  <a:lnTo>
-                    <a:pt x="517159" y="215326"/>
-                  </a:lnTo>
-                  <a:lnTo>
-                    <a:pt x="519512" y="231693"/>
-                  </a:lnTo>
-                  <a:lnTo>
-                    <a:pt x="520822" y="248176"/>
-                  </a:lnTo>
-                  <a:lnTo>
-                    <a:pt x="521085" y="264709"/>
-                  </a:lnTo>
-                  <a:lnTo>
-                    <a:pt x="520298" y="281226"/>
-                  </a:lnTo>
-                  <a:lnTo>
-                    <a:pt x="518465" y="297659"/>
-                  </a:lnTo>
-                  <a:lnTo>
-                    <a:pt x="515594" y="313943"/>
-                  </a:lnTo>
-                  <a:lnTo>
-                    <a:pt x="511696" y="330011"/>
-                  </a:lnTo>
-                  <a:lnTo>
-                    <a:pt x="506786" y="345801"/>
-                  </a:lnTo>
-                  <a:lnTo>
-                    <a:pt x="500885" y="361247"/>
-                  </a:lnTo>
-                  <a:lnTo>
-                    <a:pt x="494016" y="376288"/>
-                  </a:lnTo>
-                  <a:lnTo>
-                    <a:pt x="486207" y="390863"/>
-                  </a:lnTo>
-                  <a:lnTo>
-                    <a:pt x="477489" y="404913"/>
-                  </a:lnTo>
-                  <a:lnTo>
-                    <a:pt x="467898" y="418382"/>
-                  </a:lnTo>
-                  <a:lnTo>
-                    <a:pt x="457472" y="431216"/>
-                  </a:lnTo>
-                  <a:lnTo>
-                    <a:pt x="446253" y="443362"/>
-                  </a:lnTo>
-                  <a:lnTo>
-                    <a:pt x="434286" y="454773"/>
-                  </a:lnTo>
-                  <a:lnTo>
-                    <a:pt x="421619" y="465401"/>
-                  </a:lnTo>
-                  <a:lnTo>
-                    <a:pt x="408304" y="475205"/>
-                  </a:lnTo>
-                  <a:lnTo>
-                    <a:pt x="394394" y="484144"/>
-                  </a:lnTo>
-                  <a:lnTo>
-                    <a:pt x="379945" y="492184"/>
-                  </a:lnTo>
-                  <a:lnTo>
-                    <a:pt x="365015" y="499290"/>
-                  </a:lnTo>
-                  <a:lnTo>
-                    <a:pt x="349664" y="505436"/>
-                  </a:lnTo>
-                  <a:lnTo>
-                    <a:pt x="333955" y="510595"/>
-                  </a:lnTo>
-                  <a:lnTo>
-                    <a:pt x="317950" y="514748"/>
-                  </a:lnTo>
-                  <a:lnTo>
-                    <a:pt x="301713" y="517877"/>
-                  </a:lnTo>
-                  <a:lnTo>
-                    <a:pt x="285311" y="519970"/>
-                  </a:lnTo>
-                  <a:lnTo>
-                    <a:pt x="268810" y="521019"/>
-                  </a:lnTo>
-                  <a:lnTo>
-                    <a:pt x="252275" y="521019"/>
-                  </a:lnTo>
-                  <a:lnTo>
-                    <a:pt x="235773" y="519970"/>
-                  </a:lnTo>
-                  <a:lnTo>
-                    <a:pt x="219371" y="517877"/>
-                  </a:lnTo>
-                  <a:lnTo>
-                    <a:pt x="203135" y="514748"/>
-                  </a:lnTo>
-                  <a:lnTo>
-                    <a:pt x="187130" y="510595"/>
-                  </a:lnTo>
-                  <a:lnTo>
-                    <a:pt x="171420" y="505436"/>
-                  </a:lnTo>
-                  <a:lnTo>
-                    <a:pt x="156069" y="499290"/>
-                  </a:lnTo>
-                  <a:lnTo>
-                    <a:pt x="141140" y="492184"/>
-                  </a:lnTo>
-                  <a:lnTo>
-                    <a:pt x="126690" y="484144"/>
-                  </a:lnTo>
-                  <a:lnTo>
-                    <a:pt x="112780" y="475205"/>
-                  </a:lnTo>
-                  <a:lnTo>
-                    <a:pt x="99465" y="465401"/>
-                  </a:lnTo>
-                  <a:lnTo>
-                    <a:pt x="86799" y="454773"/>
-                  </a:lnTo>
-                  <a:lnTo>
-                    <a:pt x="74832" y="443362"/>
-                  </a:lnTo>
-                  <a:lnTo>
-                    <a:pt x="63612" y="431216"/>
-                  </a:lnTo>
-                  <a:lnTo>
-                    <a:pt x="53186" y="418382"/>
-                  </a:lnTo>
-                  <a:lnTo>
-                    <a:pt x="43595" y="404913"/>
-                  </a:lnTo>
-                  <a:lnTo>
-                    <a:pt x="34877" y="390863"/>
-                  </a:lnTo>
-                  <a:lnTo>
-                    <a:pt x="27068" y="376288"/>
-                  </a:lnTo>
-                  <a:lnTo>
-                    <a:pt x="20199" y="361247"/>
-                  </a:lnTo>
-                  <a:lnTo>
-                    <a:pt x="14298" y="345801"/>
-                  </a:lnTo>
-                  <a:lnTo>
-                    <a:pt x="9389" y="330011"/>
-                  </a:lnTo>
-                  <a:lnTo>
-                    <a:pt x="5490" y="313943"/>
-                  </a:lnTo>
-                  <a:lnTo>
-                    <a:pt x="2619" y="297659"/>
-                  </a:lnTo>
-                  <a:lnTo>
-                    <a:pt x="786" y="281226"/>
-                  </a:lnTo>
-                  <a:lnTo>
-                    <a:pt x="0" y="264709"/>
-                  </a:lnTo>
-                  <a:lnTo>
-                    <a:pt x="262" y="248176"/>
-                  </a:lnTo>
-                  <a:lnTo>
-                    <a:pt x="1572" y="231693"/>
-                  </a:lnTo>
-                  <a:lnTo>
-                    <a:pt x="3925" y="215326"/>
-                  </a:lnTo>
-                  <a:lnTo>
-                    <a:pt x="7312" y="199142"/>
-                  </a:lnTo>
-                  <a:lnTo>
-                    <a:pt x="11718" y="183205"/>
-                  </a:lnTo>
-                  <a:lnTo>
-                    <a:pt x="17126" y="167579"/>
-                  </a:lnTo>
-                  <a:lnTo>
-                    <a:pt x="23514" y="152328"/>
-                  </a:lnTo>
-                  <a:lnTo>
-                    <a:pt x="30857" y="137513"/>
-                  </a:lnTo>
-                  <a:lnTo>
-                    <a:pt x="39125" y="123193"/>
-                  </a:lnTo>
-                  <a:lnTo>
-                    <a:pt x="48284" y="109426"/>
-                  </a:lnTo>
-                  <a:lnTo>
-                    <a:pt x="58297" y="96268"/>
-                  </a:lnTo>
-                  <a:lnTo>
-                    <a:pt x="69126" y="83772"/>
-                  </a:lnTo>
-                  <a:lnTo>
-                    <a:pt x="80724" y="71988"/>
-                  </a:lnTo>
-                  <a:lnTo>
-                    <a:pt x="93047" y="60963"/>
-                  </a:lnTo>
-                  <a:lnTo>
-                    <a:pt x="106045" y="50741"/>
-                  </a:lnTo>
-                  <a:lnTo>
-                    <a:pt x="119664" y="41365"/>
-                  </a:lnTo>
-                  <a:lnTo>
-                    <a:pt x="133851" y="32871"/>
-                  </a:lnTo>
-                  <a:lnTo>
-                    <a:pt x="148548" y="25294"/>
-                  </a:lnTo>
-                  <a:lnTo>
-                    <a:pt x="163696" y="18665"/>
-                  </a:lnTo>
-                  <a:lnTo>
-                    <a:pt x="179234" y="13010"/>
-                  </a:lnTo>
-                  <a:lnTo>
-                    <a:pt x="195099" y="8351"/>
-                  </a:lnTo>
-                  <a:lnTo>
-                    <a:pt x="211228" y="4708"/>
-                  </a:lnTo>
-                  <a:lnTo>
-                    <a:pt x="227555" y="2096"/>
-                  </a:lnTo>
-                  <a:lnTo>
-                    <a:pt x="244015" y="524"/>
-                  </a:lnTo>
-                  <a:lnTo>
-                    <a:pt x="260542" y="0"/>
+                    <a:pt x="1367930" y="2590"/>
+                  </a:lnTo>
+                  <a:lnTo>
+                    <a:pt x="1449197" y="10350"/>
+                  </a:lnTo>
+                  <a:lnTo>
+                    <a:pt x="1529807" y="23248"/>
+                  </a:lnTo>
+                  <a:lnTo>
+                    <a:pt x="1609437" y="41233"/>
+                  </a:lnTo>
+                  <a:lnTo>
+                    <a:pt x="1687766" y="64233"/>
+                  </a:lnTo>
+                  <a:lnTo>
+                    <a:pt x="1764479" y="92154"/>
+                  </a:lnTo>
+                  <a:lnTo>
+                    <a:pt x="1839266" y="124884"/>
+                  </a:lnTo>
+                  <a:lnTo>
+                    <a:pt x="1911827" y="162292"/>
+                  </a:lnTo>
+                  <a:lnTo>
+                    <a:pt x="1981869" y="204227"/>
+                  </a:lnTo>
+                  <a:lnTo>
+                    <a:pt x="2049111" y="250519"/>
+                  </a:lnTo>
+                  <a:lnTo>
+                    <a:pt x="2113281" y="300983"/>
+                  </a:lnTo>
+                  <a:lnTo>
+                    <a:pt x="2174121" y="355415"/>
+                  </a:lnTo>
+                  <a:lnTo>
+                    <a:pt x="2231387" y="413597"/>
+                  </a:lnTo>
+                  <a:lnTo>
+                    <a:pt x="2284847" y="475293"/>
+                  </a:lnTo>
+                  <a:lnTo>
+                    <a:pt x="2334286" y="540256"/>
+                  </a:lnTo>
+                  <a:lnTo>
+                    <a:pt x="2379506" y="608223"/>
+                  </a:lnTo>
+                  <a:lnTo>
+                    <a:pt x="2420324" y="678922"/>
+                  </a:lnTo>
+                  <a:lnTo>
+                    <a:pt x="2456576" y="752067"/>
+                  </a:lnTo>
+                  <a:lnTo>
+                    <a:pt x="2488115" y="827364"/>
+                  </a:lnTo>
+                  <a:lnTo>
+                    <a:pt x="2514816" y="904510"/>
+                  </a:lnTo>
+                  <a:lnTo>
+                    <a:pt x="2536569" y="983194"/>
+                  </a:lnTo>
+                  <a:lnTo>
+                    <a:pt x="2553289" y="1063100"/>
+                  </a:lnTo>
+                  <a:lnTo>
+                    <a:pt x="2564907" y="1143904"/>
+                  </a:lnTo>
+                  <a:lnTo>
+                    <a:pt x="2571377" y="1225284"/>
+                  </a:lnTo>
+                  <a:lnTo>
+                    <a:pt x="2572672" y="1306909"/>
+                  </a:lnTo>
+                  <a:lnTo>
+                    <a:pt x="2568788" y="1388453"/>
+                  </a:lnTo>
+                  <a:lnTo>
+                    <a:pt x="2559739" y="1469585"/>
+                  </a:lnTo>
+                  <a:lnTo>
+                    <a:pt x="2545563" y="1549981"/>
+                  </a:lnTo>
+                  <a:lnTo>
+                    <a:pt x="2526317" y="1629316"/>
+                  </a:lnTo>
+                  <a:lnTo>
+                    <a:pt x="2502077" y="1707270"/>
+                  </a:lnTo>
+                  <a:lnTo>
+                    <a:pt x="2472943" y="1783530"/>
+                  </a:lnTo>
+                  <a:lnTo>
+                    <a:pt x="2439030" y="1857789"/>
+                  </a:lnTo>
+                  <a:lnTo>
+                    <a:pt x="2400476" y="1929747"/>
+                  </a:lnTo>
+                  <a:lnTo>
+                    <a:pt x="2357435" y="1999115"/>
+                  </a:lnTo>
+                  <a:lnTo>
+                    <a:pt x="2310082" y="2065613"/>
+                  </a:lnTo>
+                  <a:lnTo>
+                    <a:pt x="2258606" y="2128975"/>
+                  </a:lnTo>
+                  <a:lnTo>
+                    <a:pt x="2203215" y="2188944"/>
+                  </a:lnTo>
+                  <a:lnTo>
+                    <a:pt x="2144133" y="2245279"/>
+                  </a:lnTo>
+                  <a:lnTo>
+                    <a:pt x="2081596" y="2297753"/>
+                  </a:lnTo>
+                  <a:lnTo>
+                    <a:pt x="2015857" y="2346156"/>
+                  </a:lnTo>
+                  <a:lnTo>
+                    <a:pt x="1947181" y="2390292"/>
+                  </a:lnTo>
+                  <a:lnTo>
+                    <a:pt x="1875843" y="2429983"/>
+                  </a:lnTo>
+                  <a:lnTo>
+                    <a:pt x="1802132" y="2465069"/>
+                  </a:lnTo>
+                  <a:lnTo>
+                    <a:pt x="1726344" y="2495410"/>
+                  </a:lnTo>
+                  <a:lnTo>
+                    <a:pt x="1648784" y="2520884"/>
+                  </a:lnTo>
+                  <a:lnTo>
+                    <a:pt x="1569765" y="2541386"/>
+                  </a:lnTo>
+                  <a:lnTo>
+                    <a:pt x="1489604" y="2556836"/>
+                  </a:lnTo>
+                  <a:lnTo>
+                    <a:pt x="1408625" y="2567170"/>
+                  </a:lnTo>
+                  <a:lnTo>
+                    <a:pt x="1327154" y="2572348"/>
+                  </a:lnTo>
+                  <a:lnTo>
+                    <a:pt x="1245518" y="2572348"/>
+                  </a:lnTo>
+                  <a:lnTo>
+                    <a:pt x="1164046" y="2567170"/>
+                  </a:lnTo>
+                  <a:lnTo>
+                    <a:pt x="1083067" y="2556836"/>
+                  </a:lnTo>
+                  <a:lnTo>
+                    <a:pt x="1002907" y="2541386"/>
+                  </a:lnTo>
+                  <a:lnTo>
+                    <a:pt x="923887" y="2520884"/>
+                  </a:lnTo>
+                  <a:lnTo>
+                    <a:pt x="846327" y="2495410"/>
+                  </a:lnTo>
+                  <a:lnTo>
+                    <a:pt x="770539" y="2465069"/>
+                  </a:lnTo>
+                  <a:lnTo>
+                    <a:pt x="696828" y="2429983"/>
+                  </a:lnTo>
+                  <a:lnTo>
+                    <a:pt x="625491" y="2390292"/>
+                  </a:lnTo>
+                  <a:lnTo>
+                    <a:pt x="556814" y="2346156"/>
+                  </a:lnTo>
+                  <a:lnTo>
+                    <a:pt x="491075" y="2297753"/>
+                  </a:lnTo>
+                  <a:lnTo>
+                    <a:pt x="428539" y="2245279"/>
+                  </a:lnTo>
+                  <a:lnTo>
+                    <a:pt x="369456" y="2188944"/>
+                  </a:lnTo>
+                  <a:lnTo>
+                    <a:pt x="314065" y="2128975"/>
+                  </a:lnTo>
+                  <a:lnTo>
+                    <a:pt x="262590" y="2065613"/>
+                  </a:lnTo>
+                  <a:lnTo>
+                    <a:pt x="215236" y="1999115"/>
+                  </a:lnTo>
+                  <a:lnTo>
+                    <a:pt x="172196" y="1929747"/>
+                  </a:lnTo>
+                  <a:lnTo>
+                    <a:pt x="133641" y="1857789"/>
+                  </a:lnTo>
+                  <a:lnTo>
+                    <a:pt x="99729" y="1783530"/>
+                  </a:lnTo>
+                  <a:lnTo>
+                    <a:pt x="70594" y="1707270"/>
+                  </a:lnTo>
+                  <a:lnTo>
+                    <a:pt x="46355" y="1629316"/>
+                  </a:lnTo>
+                  <a:lnTo>
+                    <a:pt x="27108" y="1549981"/>
+                  </a:lnTo>
+                  <a:lnTo>
+                    <a:pt x="12932" y="1469585"/>
+                  </a:lnTo>
+                  <a:lnTo>
+                    <a:pt x="3884" y="1388453"/>
+                  </a:lnTo>
+                  <a:lnTo>
+                    <a:pt x="0" y="1306909"/>
+                  </a:lnTo>
+                  <a:lnTo>
+                    <a:pt x="1295" y="1225284"/>
+                  </a:lnTo>
+                  <a:lnTo>
+                    <a:pt x="7764" y="1143904"/>
+                  </a:lnTo>
+                  <a:lnTo>
+                    <a:pt x="19382" y="1063100"/>
+                  </a:lnTo>
+                  <a:lnTo>
+                    <a:pt x="36102" y="983194"/>
+                  </a:lnTo>
+                  <a:lnTo>
+                    <a:pt x="57856" y="904510"/>
+                  </a:lnTo>
+                  <a:lnTo>
+                    <a:pt x="84556" y="827364"/>
+                  </a:lnTo>
+                  <a:lnTo>
+                    <a:pt x="116096" y="752067"/>
+                  </a:lnTo>
+                  <a:lnTo>
+                    <a:pt x="152348" y="678922"/>
+                  </a:lnTo>
+                  <a:lnTo>
+                    <a:pt x="193166" y="608223"/>
+                  </a:lnTo>
+                  <a:lnTo>
+                    <a:pt x="238385" y="540256"/>
+                  </a:lnTo>
+                  <a:lnTo>
+                    <a:pt x="287825" y="475293"/>
+                  </a:lnTo>
+                  <a:lnTo>
+                    <a:pt x="341285" y="413597"/>
+                  </a:lnTo>
+                  <a:lnTo>
+                    <a:pt x="398550" y="355415"/>
+                  </a:lnTo>
+                  <a:lnTo>
+                    <a:pt x="459391" y="300983"/>
+                  </a:lnTo>
+                  <a:lnTo>
+                    <a:pt x="523561" y="250519"/>
+                  </a:lnTo>
+                  <a:lnTo>
+                    <a:pt x="590802" y="204227"/>
+                  </a:lnTo>
+                  <a:lnTo>
+                    <a:pt x="660845" y="162292"/>
+                  </a:lnTo>
+                  <a:lnTo>
+                    <a:pt x="733405" y="124884"/>
+                  </a:lnTo>
+                  <a:lnTo>
+                    <a:pt x="808193" y="92154"/>
+                  </a:lnTo>
+                  <a:lnTo>
+                    <a:pt x="884905" y="64233"/>
+                  </a:lnTo>
+                  <a:lnTo>
+                    <a:pt x="963234" y="41233"/>
+                  </a:lnTo>
+                  <a:lnTo>
+                    <a:pt x="1042864" y="23248"/>
+                  </a:lnTo>
+                  <a:lnTo>
+                    <a:pt x="1123475" y="10350"/>
+                  </a:lnTo>
+                  <a:lnTo>
+                    <a:pt x="1204741" y="2590"/>
+                  </a:lnTo>
+                  <a:lnTo>
+                    <a:pt x="1286336" y="0"/>
                   </a:lnTo>
                 </a:path>
               </a:pathLst>
@@ -2995,312 +2995,312 @@
           </p:nvSpPr>
           <p:spPr>
             <a:xfrm>
-              <a:off x="3091370" y="2828312"/>
-              <a:ext cx="1079390" cy="1079255"/>
+              <a:off x="1058393" y="795079"/>
+              <a:ext cx="5145344" cy="5144697"/>
             </a:xfrm>
             <a:custGeom>
               <a:avLst/>
               <a:pathLst>
-                <a:path w="1079390" h="1079255">
+                <a:path w="5145344" h="5144697">
                   <a:moveTo>
-                    <a:pt x="539695" y="0"/>
+                    <a:pt x="2572672" y="0"/>
                   </a:moveTo>
                   <a:lnTo>
-                    <a:pt x="573929" y="1086"/>
-                  </a:lnTo>
-                  <a:lnTo>
-                    <a:pt x="608025" y="4342"/>
-                  </a:lnTo>
-                  <a:lnTo>
-                    <a:pt x="641846" y="9754"/>
-                  </a:lnTo>
-                  <a:lnTo>
-                    <a:pt x="675255" y="17300"/>
-                  </a:lnTo>
-                  <a:lnTo>
-                    <a:pt x="708119" y="26949"/>
-                  </a:lnTo>
-                  <a:lnTo>
-                    <a:pt x="740305" y="38664"/>
-                  </a:lnTo>
-                  <a:lnTo>
-                    <a:pt x="771683" y="52396"/>
-                  </a:lnTo>
-                  <a:lnTo>
-                    <a:pt x="802126" y="68091"/>
-                  </a:lnTo>
-                  <a:lnTo>
-                    <a:pt x="831513" y="85685"/>
-                  </a:lnTo>
-                  <a:lnTo>
-                    <a:pt x="859725" y="105107"/>
-                  </a:lnTo>
-                  <a:lnTo>
-                    <a:pt x="886648" y="126280"/>
-                  </a:lnTo>
-                  <a:lnTo>
-                    <a:pt x="912174" y="149118"/>
-                  </a:lnTo>
-                  <a:lnTo>
-                    <a:pt x="936201" y="173528"/>
-                  </a:lnTo>
-                  <a:lnTo>
-                    <a:pt x="958630" y="199414"/>
-                  </a:lnTo>
-                  <a:lnTo>
-                    <a:pt x="979373" y="226669"/>
-                  </a:lnTo>
-                  <a:lnTo>
-                    <a:pt x="998346" y="255186"/>
-                  </a:lnTo>
-                  <a:lnTo>
-                    <a:pt x="1015471" y="284848"/>
-                  </a:lnTo>
-                  <a:lnTo>
-                    <a:pt x="1030681" y="315537"/>
-                  </a:lnTo>
-                  <a:lnTo>
-                    <a:pt x="1043914" y="347129"/>
-                  </a:lnTo>
-                  <a:lnTo>
-                    <a:pt x="1055116" y="379496"/>
-                  </a:lnTo>
-                  <a:lnTo>
-                    <a:pt x="1064243" y="412509"/>
-                  </a:lnTo>
-                  <a:lnTo>
-                    <a:pt x="1071258" y="446034"/>
-                  </a:lnTo>
-                  <a:lnTo>
-                    <a:pt x="1076133" y="479936"/>
-                  </a:lnTo>
-                  <a:lnTo>
-                    <a:pt x="1078847" y="514080"/>
-                  </a:lnTo>
-                  <a:lnTo>
-                    <a:pt x="1079390" y="548327"/>
-                  </a:lnTo>
-                  <a:lnTo>
-                    <a:pt x="1077761" y="582539"/>
-                  </a:lnTo>
-                  <a:lnTo>
-                    <a:pt x="1073964" y="616579"/>
-                  </a:lnTo>
-                  <a:lnTo>
-                    <a:pt x="1068017" y="650310"/>
-                  </a:lnTo>
-                  <a:lnTo>
-                    <a:pt x="1059942" y="683596"/>
-                  </a:lnTo>
-                  <a:lnTo>
-                    <a:pt x="1049772" y="716302"/>
-                  </a:lnTo>
-                  <a:lnTo>
-                    <a:pt x="1037548" y="748298"/>
-                  </a:lnTo>
-                  <a:lnTo>
-                    <a:pt x="1023320" y="779454"/>
-                  </a:lnTo>
-                  <a:lnTo>
-                    <a:pt x="1007144" y="809645"/>
-                  </a:lnTo>
-                  <a:lnTo>
-                    <a:pt x="989086" y="838749"/>
-                  </a:lnTo>
-                  <a:lnTo>
-                    <a:pt x="969218" y="866649"/>
-                  </a:lnTo>
-                  <a:lnTo>
-                    <a:pt x="947621" y="893233"/>
-                  </a:lnTo>
-                  <a:lnTo>
-                    <a:pt x="924381" y="918393"/>
-                  </a:lnTo>
-                  <a:lnTo>
-                    <a:pt x="899592" y="942029"/>
-                  </a:lnTo>
-                  <a:lnTo>
-                    <a:pt x="873355" y="964046"/>
-                  </a:lnTo>
-                  <a:lnTo>
-                    <a:pt x="845773" y="984353"/>
-                  </a:lnTo>
-                  <a:lnTo>
-                    <a:pt x="816959" y="1002871"/>
-                  </a:lnTo>
-                  <a:lnTo>
-                    <a:pt x="787029" y="1019524"/>
-                  </a:lnTo>
-                  <a:lnTo>
-                    <a:pt x="756103" y="1034245"/>
-                  </a:lnTo>
-                  <a:lnTo>
-                    <a:pt x="724305" y="1046975"/>
-                  </a:lnTo>
-                  <a:lnTo>
-                    <a:pt x="691764" y="1057662"/>
-                  </a:lnTo>
-                  <a:lnTo>
-                    <a:pt x="658611" y="1066264"/>
-                  </a:lnTo>
-                  <a:lnTo>
-                    <a:pt x="624978" y="1072746"/>
-                  </a:lnTo>
-                  <a:lnTo>
-                    <a:pt x="591003" y="1077082"/>
-                  </a:lnTo>
-                  <a:lnTo>
-                    <a:pt x="556821" y="1079255"/>
-                  </a:lnTo>
-                  <a:lnTo>
-                    <a:pt x="522569" y="1079255"/>
-                  </a:lnTo>
-                  <a:lnTo>
-                    <a:pt x="488387" y="1077082"/>
-                  </a:lnTo>
-                  <a:lnTo>
-                    <a:pt x="454412" y="1072746"/>
-                  </a:lnTo>
-                  <a:lnTo>
-                    <a:pt x="420779" y="1066264"/>
-                  </a:lnTo>
-                  <a:lnTo>
-                    <a:pt x="387626" y="1057662"/>
-                  </a:lnTo>
-                  <a:lnTo>
-                    <a:pt x="355085" y="1046975"/>
-                  </a:lnTo>
-                  <a:lnTo>
-                    <a:pt x="323287" y="1034245"/>
-                  </a:lnTo>
-                  <a:lnTo>
-                    <a:pt x="292361" y="1019524"/>
-                  </a:lnTo>
-                  <a:lnTo>
-                    <a:pt x="262431" y="1002871"/>
-                  </a:lnTo>
-                  <a:lnTo>
-                    <a:pt x="233617" y="984353"/>
-                  </a:lnTo>
-                  <a:lnTo>
-                    <a:pt x="206035" y="964046"/>
-                  </a:lnTo>
-                  <a:lnTo>
-                    <a:pt x="179797" y="942029"/>
-                  </a:lnTo>
-                  <a:lnTo>
-                    <a:pt x="155009" y="918393"/>
-                  </a:lnTo>
-                  <a:lnTo>
-                    <a:pt x="131769" y="893233"/>
-                  </a:lnTo>
-                  <a:lnTo>
-                    <a:pt x="110172" y="866649"/>
-                  </a:lnTo>
-                  <a:lnTo>
-                    <a:pt x="90304" y="838749"/>
-                  </a:lnTo>
-                  <a:lnTo>
-                    <a:pt x="72246" y="809645"/>
-                  </a:lnTo>
-                  <a:lnTo>
-                    <a:pt x="56070" y="779454"/>
-                  </a:lnTo>
-                  <a:lnTo>
-                    <a:pt x="41842" y="748298"/>
-                  </a:lnTo>
-                  <a:lnTo>
-                    <a:pt x="29618" y="716302"/>
-                  </a:lnTo>
-                  <a:lnTo>
-                    <a:pt x="19448" y="683596"/>
-                  </a:lnTo>
-                  <a:lnTo>
-                    <a:pt x="11373" y="650310"/>
-                  </a:lnTo>
-                  <a:lnTo>
-                    <a:pt x="5426" y="616579"/>
-                  </a:lnTo>
-                  <a:lnTo>
-                    <a:pt x="1629" y="582539"/>
-                  </a:lnTo>
-                  <a:lnTo>
-                    <a:pt x="0" y="548327"/>
-                  </a:lnTo>
-                  <a:lnTo>
-                    <a:pt x="543" y="514080"/>
-                  </a:lnTo>
-                  <a:lnTo>
-                    <a:pt x="3257" y="479936"/>
-                  </a:lnTo>
-                  <a:lnTo>
-                    <a:pt x="8132" y="446034"/>
-                  </a:lnTo>
-                  <a:lnTo>
-                    <a:pt x="15147" y="412509"/>
-                  </a:lnTo>
-                  <a:lnTo>
-                    <a:pt x="24274" y="379496"/>
-                  </a:lnTo>
-                  <a:lnTo>
-                    <a:pt x="35476" y="347129"/>
-                  </a:lnTo>
-                  <a:lnTo>
-                    <a:pt x="48709" y="315537"/>
-                  </a:lnTo>
-                  <a:lnTo>
-                    <a:pt x="63919" y="284848"/>
-                  </a:lnTo>
-                  <a:lnTo>
-                    <a:pt x="81044" y="255186"/>
-                  </a:lnTo>
-                  <a:lnTo>
-                    <a:pt x="100017" y="226669"/>
-                  </a:lnTo>
-                  <a:lnTo>
-                    <a:pt x="120760" y="199414"/>
-                  </a:lnTo>
-                  <a:lnTo>
-                    <a:pt x="143189" y="173528"/>
-                  </a:lnTo>
-                  <a:lnTo>
-                    <a:pt x="167216" y="149118"/>
-                  </a:lnTo>
-                  <a:lnTo>
-                    <a:pt x="192742" y="126280"/>
-                  </a:lnTo>
-                  <a:lnTo>
-                    <a:pt x="219665" y="105107"/>
-                  </a:lnTo>
-                  <a:lnTo>
-                    <a:pt x="247877" y="85685"/>
-                  </a:lnTo>
-                  <a:lnTo>
-                    <a:pt x="277264" y="68091"/>
-                  </a:lnTo>
-                  <a:lnTo>
-                    <a:pt x="307707" y="52396"/>
-                  </a:lnTo>
-                  <a:lnTo>
-                    <a:pt x="339085" y="38664"/>
-                  </a:lnTo>
-                  <a:lnTo>
-                    <a:pt x="371271" y="26949"/>
-                  </a:lnTo>
-                  <a:lnTo>
-                    <a:pt x="404134" y="17300"/>
-                  </a:lnTo>
-                  <a:lnTo>
-                    <a:pt x="437544" y="9754"/>
-                  </a:lnTo>
-                  <a:lnTo>
-                    <a:pt x="471365" y="4342"/>
-                  </a:lnTo>
-                  <a:lnTo>
-                    <a:pt x="505461" y="1086"/>
-                  </a:lnTo>
-                  <a:lnTo>
-                    <a:pt x="539695" y="0"/>
+                    <a:pt x="2735861" y="5180"/>
+                  </a:lnTo>
+                  <a:lnTo>
+                    <a:pt x="2898394" y="20700"/>
+                  </a:lnTo>
+                  <a:lnTo>
+                    <a:pt x="3059615" y="46497"/>
+                  </a:lnTo>
+                  <a:lnTo>
+                    <a:pt x="3218875" y="82467"/>
+                  </a:lnTo>
+                  <a:lnTo>
+                    <a:pt x="3375533" y="128466"/>
+                  </a:lnTo>
+                  <a:lnTo>
+                    <a:pt x="3528958" y="184309"/>
+                  </a:lnTo>
+                  <a:lnTo>
+                    <a:pt x="3678533" y="249769"/>
+                  </a:lnTo>
+                  <a:lnTo>
+                    <a:pt x="3823654" y="324585"/>
+                  </a:lnTo>
+                  <a:lnTo>
+                    <a:pt x="3963739" y="408454"/>
+                  </a:lnTo>
+                  <a:lnTo>
+                    <a:pt x="4098222" y="501038"/>
+                  </a:lnTo>
+                  <a:lnTo>
+                    <a:pt x="4226562" y="601966"/>
+                  </a:lnTo>
+                  <a:lnTo>
+                    <a:pt x="4348243" y="710831"/>
+                  </a:lnTo>
+                  <a:lnTo>
+                    <a:pt x="4462774" y="827194"/>
+                  </a:lnTo>
+                  <a:lnTo>
+                    <a:pt x="4569694" y="950586"/>
+                  </a:lnTo>
+                  <a:lnTo>
+                    <a:pt x="4668573" y="1080512"/>
+                  </a:lnTo>
+                  <a:lnTo>
+                    <a:pt x="4759012" y="1216447"/>
+                  </a:lnTo>
+                  <a:lnTo>
+                    <a:pt x="4840648" y="1357844"/>
+                  </a:lnTo>
+                  <a:lnTo>
+                    <a:pt x="4913152" y="1504134"/>
+                  </a:lnTo>
+                  <a:lnTo>
+                    <a:pt x="4976231" y="1654729"/>
+                  </a:lnTo>
+                  <a:lnTo>
+                    <a:pt x="5029632" y="1809021"/>
+                  </a:lnTo>
+                  <a:lnTo>
+                    <a:pt x="5073139" y="1966389"/>
+                  </a:lnTo>
+                  <a:lnTo>
+                    <a:pt x="5106579" y="2126200"/>
+                  </a:lnTo>
+                  <a:lnTo>
+                    <a:pt x="5129815" y="2287809"/>
+                  </a:lnTo>
+                  <a:lnTo>
+                    <a:pt x="5142754" y="2450568"/>
+                  </a:lnTo>
+                  <a:lnTo>
+                    <a:pt x="5145344" y="2613819"/>
+                  </a:lnTo>
+                  <a:lnTo>
+                    <a:pt x="5137576" y="2776906"/>
+                  </a:lnTo>
+                  <a:lnTo>
+                    <a:pt x="5119479" y="2939171"/>
+                  </a:lnTo>
+                  <a:lnTo>
+                    <a:pt x="5091127" y="3099963"/>
+                  </a:lnTo>
+                  <a:lnTo>
+                    <a:pt x="5052634" y="3258632"/>
+                  </a:lnTo>
+                  <a:lnTo>
+                    <a:pt x="5004155" y="3414540"/>
+                  </a:lnTo>
+                  <a:lnTo>
+                    <a:pt x="4945886" y="3567060"/>
+                  </a:lnTo>
+                  <a:lnTo>
+                    <a:pt x="4878061" y="3715578"/>
+                  </a:lnTo>
+                  <a:lnTo>
+                    <a:pt x="4800952" y="3859494"/>
+                  </a:lnTo>
+                  <a:lnTo>
+                    <a:pt x="4714871" y="3998230"/>
+                  </a:lnTo>
+                  <a:lnTo>
+                    <a:pt x="4620164" y="4131227"/>
+                  </a:lnTo>
+                  <a:lnTo>
+                    <a:pt x="4517213" y="4257950"/>
+                  </a:lnTo>
+                  <a:lnTo>
+                    <a:pt x="4406431" y="4377888"/>
+                  </a:lnTo>
+                  <a:lnTo>
+                    <a:pt x="4288266" y="4490558"/>
+                  </a:lnTo>
+                  <a:lnTo>
+                    <a:pt x="4163193" y="4595507"/>
+                  </a:lnTo>
+                  <a:lnTo>
+                    <a:pt x="4031715" y="4692313"/>
+                  </a:lnTo>
+                  <a:lnTo>
+                    <a:pt x="3894362" y="4780584"/>
+                  </a:lnTo>
+                  <a:lnTo>
+                    <a:pt x="3751687" y="4859966"/>
+                  </a:lnTo>
+                  <a:lnTo>
+                    <a:pt x="3604265" y="4930139"/>
+                  </a:lnTo>
+                  <a:lnTo>
+                    <a:pt x="3452688" y="4990821"/>
+                  </a:lnTo>
+                  <a:lnTo>
+                    <a:pt x="3297569" y="5041768"/>
+                  </a:lnTo>
+                  <a:lnTo>
+                    <a:pt x="3139530" y="5082773"/>
+                  </a:lnTo>
+                  <a:lnTo>
+                    <a:pt x="2979209" y="5113672"/>
+                  </a:lnTo>
+                  <a:lnTo>
+                    <a:pt x="2817251" y="5134341"/>
+                  </a:lnTo>
+                  <a:lnTo>
+                    <a:pt x="2654308" y="5144697"/>
+                  </a:lnTo>
+                  <a:lnTo>
+                    <a:pt x="2491036" y="5144697"/>
+                  </a:lnTo>
+                  <a:lnTo>
+                    <a:pt x="2328093" y="5134341"/>
+                  </a:lnTo>
+                  <a:lnTo>
+                    <a:pt x="2166135" y="5113672"/>
+                  </a:lnTo>
+                  <a:lnTo>
+                    <a:pt x="2005814" y="5082773"/>
+                  </a:lnTo>
+                  <a:lnTo>
+                    <a:pt x="1847775" y="5041768"/>
+                  </a:lnTo>
+                  <a:lnTo>
+                    <a:pt x="1692655" y="4990821"/>
+                  </a:lnTo>
+                  <a:lnTo>
+                    <a:pt x="1541079" y="4930139"/>
+                  </a:lnTo>
+                  <a:lnTo>
+                    <a:pt x="1393657" y="4859966"/>
+                  </a:lnTo>
+                  <a:lnTo>
+                    <a:pt x="1250982" y="4780584"/>
+                  </a:lnTo>
+                  <a:lnTo>
+                    <a:pt x="1113629" y="4692313"/>
+                  </a:lnTo>
+                  <a:lnTo>
+                    <a:pt x="982151" y="4595507"/>
+                  </a:lnTo>
+                  <a:lnTo>
+                    <a:pt x="857078" y="4490558"/>
+                  </a:lnTo>
+                  <a:lnTo>
+                    <a:pt x="738912" y="4377888"/>
+                  </a:lnTo>
+                  <a:lnTo>
+                    <a:pt x="628131" y="4257950"/>
+                  </a:lnTo>
+                  <a:lnTo>
+                    <a:pt x="525180" y="4131227"/>
+                  </a:lnTo>
+                  <a:lnTo>
+                    <a:pt x="430473" y="3998230"/>
+                  </a:lnTo>
+                  <a:lnTo>
+                    <a:pt x="344392" y="3859494"/>
+                  </a:lnTo>
+                  <a:lnTo>
+                    <a:pt x="267283" y="3715578"/>
+                  </a:lnTo>
+                  <a:lnTo>
+                    <a:pt x="199458" y="3567060"/>
+                  </a:lnTo>
+                  <a:lnTo>
+                    <a:pt x="141188" y="3414540"/>
+                  </a:lnTo>
+                  <a:lnTo>
+                    <a:pt x="92710" y="3258632"/>
+                  </a:lnTo>
+                  <a:lnTo>
+                    <a:pt x="54217" y="3099963"/>
+                  </a:lnTo>
+                  <a:lnTo>
+                    <a:pt x="25865" y="2939171"/>
+                  </a:lnTo>
+                  <a:lnTo>
+                    <a:pt x="7768" y="2776906"/>
+                  </a:lnTo>
+                  <a:lnTo>
+                    <a:pt x="0" y="2613819"/>
+                  </a:lnTo>
+                  <a:lnTo>
+                    <a:pt x="2590" y="2450568"/>
+                  </a:lnTo>
+                  <a:lnTo>
+                    <a:pt x="15529" y="2287809"/>
+                  </a:lnTo>
+                  <a:lnTo>
+                    <a:pt x="38765" y="2126200"/>
+                  </a:lnTo>
+                  <a:lnTo>
+                    <a:pt x="72204" y="1966389"/>
+                  </a:lnTo>
+                  <a:lnTo>
+                    <a:pt x="115712" y="1809021"/>
+                  </a:lnTo>
+                  <a:lnTo>
+                    <a:pt x="169113" y="1654729"/>
+                  </a:lnTo>
+                  <a:lnTo>
+                    <a:pt x="232192" y="1504134"/>
+                  </a:lnTo>
+                  <a:lnTo>
+                    <a:pt x="304696" y="1357844"/>
+                  </a:lnTo>
+                  <a:lnTo>
+                    <a:pt x="386332" y="1216447"/>
+                  </a:lnTo>
+                  <a:lnTo>
+                    <a:pt x="476771" y="1080512"/>
+                  </a:lnTo>
+                  <a:lnTo>
+                    <a:pt x="575650" y="950586"/>
+                  </a:lnTo>
+                  <a:lnTo>
+                    <a:pt x="682570" y="827194"/>
+                  </a:lnTo>
+                  <a:lnTo>
+                    <a:pt x="797101" y="710831"/>
+                  </a:lnTo>
+                  <a:lnTo>
+                    <a:pt x="918782" y="601966"/>
+                  </a:lnTo>
+                  <a:lnTo>
+                    <a:pt x="1047122" y="501038"/>
+                  </a:lnTo>
+                  <a:lnTo>
+                    <a:pt x="1181605" y="408454"/>
+                  </a:lnTo>
+                  <a:lnTo>
+                    <a:pt x="1321690" y="324585"/>
+                  </a:lnTo>
+                  <a:lnTo>
+                    <a:pt x="1466811" y="249769"/>
+                  </a:lnTo>
+                  <a:lnTo>
+                    <a:pt x="1616386" y="184309"/>
+                  </a:lnTo>
+                  <a:lnTo>
+                    <a:pt x="1769811" y="128466"/>
+                  </a:lnTo>
+                  <a:lnTo>
+                    <a:pt x="1926469" y="82467"/>
+                  </a:lnTo>
+                  <a:lnTo>
+                    <a:pt x="2085729" y="46497"/>
+                  </a:lnTo>
+                  <a:lnTo>
+                    <a:pt x="2246950" y="20700"/>
+                  </a:lnTo>
+                  <a:lnTo>
+                    <a:pt x="2409482" y="5180"/>
+                  </a:lnTo>
+                  <a:lnTo>
+                    <a:pt x="2572672" y="0"/>
                   </a:lnTo>
                 </a:path>
               </a:pathLst>
@@ -7471,8 +7471,8 @@
           </p:nvSpPr>
           <p:spPr>
             <a:xfrm>
-              <a:off x="3322378" y="2997481"/>
-              <a:ext cx="617375" cy="178704"/>
+              <a:off x="3242517" y="1971559"/>
+              <a:ext cx="777096" cy="178704"/>
             </a:xfrm>
             <a:prstGeom prst="rect">
               <a:avLst/>
@@ -7504,60 +7504,14 @@
                   <a:latin typeface="Helvetica"/>
                   <a:cs typeface="Helvetica"/>
                 </a:rPr>
-                <a:t>14(4%)</a:t>
+                <a:t>29(8.3%)</a:t>
               </a:r>
             </a:p>
           </p:txBody>
         </p:sp>
         <p:sp>
           <p:nvSpPr>
-            <p:cNvPr id="78" name="tx78"/>
-            <p:cNvSpPr/>
-            <p:nvPr/>
-          </p:nvSpPr>
-          <p:spPr>
-            <a:xfrm>
-              <a:off x="3322378" y="2718294"/>
-              <a:ext cx="617375" cy="178704"/>
-            </a:xfrm>
-            <a:prstGeom prst="rect">
-              <a:avLst/>
-            </a:prstGeom>
-            <a:noFill/>
-          </p:spPr>
-          <p:txBody>
-            <a:bodyPr lIns="0" rIns="0" tIns="0" bIns="0" anchorCtr="1" anchor="ctr" wrap="none"/>
-            <a:lstStyle/>
-            <a:p>
-              <a:pPr algn="l" marL="0" marR="0" indent="0">
-                <a:lnSpc>
-                  <a:spcPts val="1507"/>
-                </a:lnSpc>
-                <a:spcBef>
-                  <a:spcPts val="0"/>
-                </a:spcBef>
-                <a:spcAft>
-                  <a:spcPts val="0"/>
-                </a:spcAft>
-              </a:pPr>
-              <a:r>
-                <a:rPr sz="1507">
-                  <a:solidFill>
-                    <a:srgbClr val="222222">
-                      <a:alpha val="100000"/>
-                    </a:srgbClr>
-                  </a:solidFill>
-                  <a:latin typeface="Helvetica"/>
-                  <a:cs typeface="Helvetica"/>
-                </a:rPr>
-                <a:t>29(8%)</a:t>
-              </a:r>
-            </a:p>
-          </p:txBody>
-        </p:sp>
-        <p:sp>
-          <p:nvSpPr>
-            <p:cNvPr id="79" name="pl79"/>
+            <p:cNvPr id="78" name="pl78"/>
             <p:cNvSpPr/>
             <p:nvPr/>
           </p:nvSpPr>
@@ -7681,7 +7635,7 @@
         </p:sp>
         <p:sp>
           <p:nvSpPr>
-            <p:cNvPr id="80" name="pl80"/>
+            <p:cNvPr id="79" name="pl79"/>
             <p:cNvSpPr/>
             <p:nvPr/>
           </p:nvSpPr>
@@ -7805,7 +7759,7 @@
         </p:sp>
         <p:sp>
           <p:nvSpPr>
-            <p:cNvPr id="81" name="pl81"/>
+            <p:cNvPr id="80" name="pl80"/>
             <p:cNvSpPr/>
             <p:nvPr/>
           </p:nvSpPr>
@@ -7929,7 +7883,7 @@
         </p:sp>
         <p:sp>
           <p:nvSpPr>
-            <p:cNvPr id="82" name="pl82"/>
+            <p:cNvPr id="81" name="pl81"/>
             <p:cNvSpPr/>
             <p:nvPr/>
           </p:nvSpPr>
@@ -8053,7 +8007,7 @@
         </p:sp>
         <p:sp>
           <p:nvSpPr>
-            <p:cNvPr id="83" name="pl83"/>
+            <p:cNvPr id="82" name="pl82"/>
             <p:cNvSpPr/>
             <p:nvPr/>
           </p:nvSpPr>
@@ -8177,7 +8131,7 @@
         </p:sp>
         <p:sp>
           <p:nvSpPr>
-            <p:cNvPr id="84" name="pl84"/>
+            <p:cNvPr id="83" name="pl83"/>
             <p:cNvSpPr/>
             <p:nvPr/>
           </p:nvSpPr>
@@ -8301,7 +8255,7 @@
         </p:sp>
         <p:sp>
           <p:nvSpPr>
-            <p:cNvPr id="85" name="pl85"/>
+            <p:cNvPr id="84" name="pl84"/>
             <p:cNvSpPr/>
             <p:nvPr/>
           </p:nvSpPr>
@@ -8425,7 +8379,7 @@
         </p:sp>
         <p:sp>
           <p:nvSpPr>
-            <p:cNvPr id="86" name="pl86"/>
+            <p:cNvPr id="85" name="pl85"/>
             <p:cNvSpPr/>
             <p:nvPr/>
           </p:nvSpPr>
@@ -8549,7 +8503,7 @@
         </p:sp>
         <p:sp>
           <p:nvSpPr>
-            <p:cNvPr id="87" name="tx87"/>
+            <p:cNvPr id="86" name="tx86"/>
             <p:cNvSpPr/>
             <p:nvPr/>
           </p:nvSpPr>
@@ -8595,7 +8549,7 @@
         </p:sp>
         <p:sp>
           <p:nvSpPr>
-            <p:cNvPr id="88" name="tx88"/>
+            <p:cNvPr id="87" name="tx87"/>
             <p:cNvSpPr/>
             <p:nvPr/>
           </p:nvSpPr>
@@ -8641,7 +8595,7 @@
         </p:sp>
         <p:sp>
           <p:nvSpPr>
-            <p:cNvPr id="89" name="tx89"/>
+            <p:cNvPr id="88" name="tx88"/>
             <p:cNvSpPr/>
             <p:nvPr/>
           </p:nvSpPr>
@@ -8687,7 +8641,7 @@
         </p:sp>
         <p:sp>
           <p:nvSpPr>
-            <p:cNvPr id="90" name="tx90"/>
+            <p:cNvPr id="89" name="tx89"/>
             <p:cNvSpPr/>
             <p:nvPr/>
           </p:nvSpPr>
@@ -8733,7 +8687,7 @@
         </p:sp>
         <p:sp>
           <p:nvSpPr>
-            <p:cNvPr id="91" name="tx91"/>
+            <p:cNvPr id="90" name="tx90"/>
             <p:cNvSpPr/>
             <p:nvPr/>
           </p:nvSpPr>
@@ -8779,7 +8733,7 @@
         </p:sp>
         <p:sp>
           <p:nvSpPr>
-            <p:cNvPr id="92" name="tx92"/>
+            <p:cNvPr id="91" name="tx91"/>
             <p:cNvSpPr/>
             <p:nvPr/>
           </p:nvSpPr>
@@ -8825,7 +8779,7 @@
         </p:sp>
         <p:sp>
           <p:nvSpPr>
-            <p:cNvPr id="93" name="tx93"/>
+            <p:cNvPr id="92" name="tx92"/>
             <p:cNvSpPr/>
             <p:nvPr/>
           </p:nvSpPr>
@@ -8871,7 +8825,7 @@
         </p:sp>
         <p:sp>
           <p:nvSpPr>
-            <p:cNvPr id="94" name="tx94"/>
+            <p:cNvPr id="93" name="tx93"/>
             <p:cNvSpPr/>
             <p:nvPr/>
           </p:nvSpPr>
@@ -8917,7 +8871,7 @@
         </p:sp>
         <p:sp>
           <p:nvSpPr>
-            <p:cNvPr id="95" name="rc95"/>
+            <p:cNvPr id="94" name="rc94"/>
             <p:cNvSpPr/>
             <p:nvPr/>
           </p:nvSpPr>
@@ -8952,7 +8906,7 @@
         </p:sp>
         <p:sp>
           <p:nvSpPr>
-            <p:cNvPr id="96" name="pl96"/>
+            <p:cNvPr id="95" name="pl95"/>
             <p:cNvSpPr/>
             <p:nvPr/>
           </p:nvSpPr>
@@ -8992,7 +8946,7 @@
         </p:sp>
         <p:sp>
           <p:nvSpPr>
-            <p:cNvPr id="97" name="pt97"/>
+            <p:cNvPr id="96" name="pt96"/>
             <p:cNvSpPr/>
             <p:nvPr/>
           </p:nvSpPr>
@@ -9027,7 +8981,7 @@
         </p:sp>
         <p:sp>
           <p:nvSpPr>
-            <p:cNvPr id="98" name="rc98"/>
+            <p:cNvPr id="97" name="rc97"/>
             <p:cNvSpPr/>
             <p:nvPr/>
           </p:nvSpPr>
@@ -9062,7 +9016,7 @@
         </p:sp>
         <p:sp>
           <p:nvSpPr>
-            <p:cNvPr id="99" name="pl99"/>
+            <p:cNvPr id="98" name="pl98"/>
             <p:cNvSpPr/>
             <p:nvPr/>
           </p:nvSpPr>
@@ -9102,7 +9056,7 @@
         </p:sp>
         <p:sp>
           <p:nvSpPr>
-            <p:cNvPr id="100" name="pt100"/>
+            <p:cNvPr id="99" name="pt99"/>
             <p:cNvSpPr/>
             <p:nvPr/>
           </p:nvSpPr>
@@ -9137,7 +9091,7 @@
         </p:sp>
         <p:sp>
           <p:nvSpPr>
-            <p:cNvPr id="101" name="rc101"/>
+            <p:cNvPr id="100" name="rc100"/>
             <p:cNvSpPr/>
             <p:nvPr/>
           </p:nvSpPr>
@@ -9172,7 +9126,7 @@
         </p:sp>
         <p:sp>
           <p:nvSpPr>
-            <p:cNvPr id="102" name="pl102"/>
+            <p:cNvPr id="101" name="pl101"/>
             <p:cNvSpPr/>
             <p:nvPr/>
           </p:nvSpPr>
@@ -9212,7 +9166,7 @@
         </p:sp>
         <p:sp>
           <p:nvSpPr>
-            <p:cNvPr id="103" name="pt103"/>
+            <p:cNvPr id="102" name="pt102"/>
             <p:cNvSpPr/>
             <p:nvPr/>
           </p:nvSpPr>
@@ -9247,7 +9201,7 @@
         </p:sp>
         <p:sp>
           <p:nvSpPr>
-            <p:cNvPr id="104" name="rc104"/>
+            <p:cNvPr id="103" name="rc103"/>
             <p:cNvSpPr/>
             <p:nvPr/>
           </p:nvSpPr>
@@ -9282,7 +9236,7 @@
         </p:sp>
         <p:sp>
           <p:nvSpPr>
-            <p:cNvPr id="105" name="pl105"/>
+            <p:cNvPr id="104" name="pl104"/>
             <p:cNvSpPr/>
             <p:nvPr/>
           </p:nvSpPr>
@@ -9322,7 +9276,7 @@
         </p:sp>
         <p:sp>
           <p:nvSpPr>
-            <p:cNvPr id="106" name="pt106"/>
+            <p:cNvPr id="105" name="pt105"/>
             <p:cNvSpPr/>
             <p:nvPr/>
           </p:nvSpPr>
@@ -9357,7 +9311,7 @@
         </p:sp>
         <p:sp>
           <p:nvSpPr>
-            <p:cNvPr id="107" name="rc107"/>
+            <p:cNvPr id="106" name="rc106"/>
             <p:cNvSpPr/>
             <p:nvPr/>
           </p:nvSpPr>
@@ -9392,7 +9346,7 @@
         </p:sp>
         <p:sp>
           <p:nvSpPr>
-            <p:cNvPr id="108" name="pl108"/>
+            <p:cNvPr id="107" name="pl107"/>
             <p:cNvSpPr/>
             <p:nvPr/>
           </p:nvSpPr>
@@ -9432,7 +9386,7 @@
         </p:sp>
         <p:sp>
           <p:nvSpPr>
-            <p:cNvPr id="109" name="pt109"/>
+            <p:cNvPr id="108" name="pt108"/>
             <p:cNvSpPr/>
             <p:nvPr/>
           </p:nvSpPr>
@@ -9467,7 +9421,7 @@
         </p:sp>
         <p:sp>
           <p:nvSpPr>
-            <p:cNvPr id="110" name="rc110"/>
+            <p:cNvPr id="109" name="rc109"/>
             <p:cNvSpPr/>
             <p:nvPr/>
           </p:nvSpPr>
@@ -9502,7 +9456,7 @@
         </p:sp>
         <p:sp>
           <p:nvSpPr>
-            <p:cNvPr id="111" name="pl111"/>
+            <p:cNvPr id="110" name="pl110"/>
             <p:cNvSpPr/>
             <p:nvPr/>
           </p:nvSpPr>
@@ -9542,7 +9496,7 @@
         </p:sp>
         <p:sp>
           <p:nvSpPr>
-            <p:cNvPr id="112" name="pt112"/>
+            <p:cNvPr id="111" name="pt111"/>
             <p:cNvSpPr/>
             <p:nvPr/>
           </p:nvSpPr>
@@ -9577,7 +9531,7 @@
         </p:sp>
         <p:sp>
           <p:nvSpPr>
-            <p:cNvPr id="113" name="tx113"/>
+            <p:cNvPr id="112" name="tx112"/>
             <p:cNvSpPr/>
             <p:nvPr/>
           </p:nvSpPr>
@@ -9623,7 +9577,7 @@
         </p:sp>
         <p:sp>
           <p:nvSpPr>
-            <p:cNvPr id="114" name="tx114"/>
+            <p:cNvPr id="113" name="tx113"/>
             <p:cNvSpPr/>
             <p:nvPr/>
           </p:nvSpPr>
@@ -9669,7 +9623,7 @@
         </p:sp>
         <p:sp>
           <p:nvSpPr>
-            <p:cNvPr id="115" name="tx115"/>
+            <p:cNvPr id="114" name="tx114"/>
             <p:cNvSpPr/>
             <p:nvPr/>
           </p:nvSpPr>
@@ -9715,7 +9669,7 @@
         </p:sp>
         <p:sp>
           <p:nvSpPr>
-            <p:cNvPr id="116" name="tx116"/>
+            <p:cNvPr id="115" name="tx115"/>
             <p:cNvSpPr/>
             <p:nvPr/>
           </p:nvSpPr>
@@ -9761,7 +9715,7 @@
         </p:sp>
         <p:sp>
           <p:nvSpPr>
-            <p:cNvPr id="117" name="tx117"/>
+            <p:cNvPr id="116" name="tx116"/>
             <p:cNvSpPr/>
             <p:nvPr/>
           </p:nvSpPr>
@@ -9807,7 +9761,7 @@
         </p:sp>
         <p:sp>
           <p:nvSpPr>
-            <p:cNvPr id="118" name="tx118"/>
+            <p:cNvPr id="117" name="tx117"/>
             <p:cNvSpPr/>
             <p:nvPr/>
           </p:nvSpPr>

</xml_diff>